<commit_message>
Endre merkenavn fra ay.no til a5.no
</commit_message>
<xml_diff>
--- a/public/filer/01-Bompenger-per-kilometer.pptx
+++ b/public/filer/01-Bompenger-per-kilometer.pptx
@@ -2717,7 +2717,7 @@
                 <a:ea typeface="Calibri" pitchFamily="34" charset="-122"/>
                 <a:cs typeface="Calibri" pitchFamily="34" charset="-120"/>
               </a:rPr>
-              <a:t>Avsender: [Ditt navn]  ·  [din e-post]  ·  Oslo, juni 2026</a:t>
+              <a:t>Avsender: André Monsen  ·  andre@leasing.no  ·  Rong, oktober 2026</a:t>
             </a:r>
             <a:endParaRPr lang="en-US" sz="1300" dirty="0"/>
           </a:p>
@@ -4460,7 +4460,7 @@
                 <a:ea typeface="Consolas" pitchFamily="34" charset="-122"/>
                 <a:cs typeface="Consolas" pitchFamily="34" charset="-120"/>
               </a:rPr>
-              <a:t>[ din-nettside.no ]</a:t>
+              <a:t>[ a5.no/bompenger ]</a:t>
             </a:r>
             <a:endParaRPr lang="en-US" sz="2400" dirty="0"/>
           </a:p>
@@ -4502,7 +4502,7 @@
                 <a:ea typeface="Calibri" pitchFamily="34" charset="-122"/>
                 <a:cs typeface="Calibri" pitchFamily="34" charset="-120"/>
               </a:rPr>
-              <a:t>Erstatt med adressen til nettsiden du setter opp.</a:t>
+              <a:t>Åpen på nett — les hele saken og regn selv.</a:t>
             </a:r>
             <a:endParaRPr lang="en-US" sz="1300" dirty="0"/>
           </a:p>
@@ -4541,7 +4541,7 @@
                 <a:ea typeface="Calibri" pitchFamily="34" charset="-122"/>
                 <a:cs typeface="Calibri" pitchFamily="34" charset="-120"/>
               </a:rPr>
-              <a:t>Åpen kildekode · ingen innlogging · ingen sporing</a:t>
+              <a:t>Åpen kildekode · ingen innlogging · anonym telling</a:t>
             </a:r>
             <a:endParaRPr lang="en-US" sz="1200" dirty="0"/>
           </a:p>

</xml_diff>